<commit_message>
Improve benchmark charts: per-page sources, better scale, aligned labels
- Add source footer to each slide (Anthropic/Vellum/HundredTabs/AI Magic)
- Adjust y-axis scales per chart to maximize visibility:
  • SWE Verified 60-100%, SWE Pro 40-80%
  • Terminal/OSWorld 60-90%, GPQA 80-100%, HLE 30-60%
  • Math split into two charts (90-100% vs 40-60%)
- Remove line breaks from model labels for cleaner alignment
- Increase data label font size and add bold for readability

Co-authored-by: Cursor <cursoragent@cursor.com>
</commit_message>
<xml_diff>
--- a/외부AI_4종_벤치마크_비교.pptx
+++ b/외부AI_4종_벤치마크_비교.pptx
@@ -133,7 +133,7 @@
               </a:defRPr>
             </a:pPr>
             <a:r>
-              <a:t>영역별 평균 점수 — 어디가 강한지 큰 그림 (%)</a:t>
+              <a:t>영역별 평균 점수 (%)</a:t>
             </a:r>
           </a:p>
         </c:rich>
@@ -174,12 +174,10 @@
               <c:strCache>
                 <c:ptCount val="2"/>
                 <c:pt idx="0">
-                  <c:v>코딩
-(평균)</c:v>
+                  <c:v>코딩 (평균)</c:v>
                 </c:pt>
                 <c:pt idx="1">
-                  <c:v>추론
-(평균)</c:v>
+                  <c:v>추론 (평균)</c:v>
                 </c:pt>
               </c:strCache>
             </c:strRef>
@@ -228,12 +226,10 @@
               <c:strCache>
                 <c:ptCount val="2"/>
                 <c:pt idx="0">
-                  <c:v>코딩
-(평균)</c:v>
+                  <c:v>코딩 (평균)</c:v>
                 </c:pt>
                 <c:pt idx="1">
-                  <c:v>추론
-(평균)</c:v>
+                  <c:v>추론 (평균)</c:v>
                 </c:pt>
               </c:strCache>
             </c:strRef>
@@ -282,12 +278,10 @@
               <c:strCache>
                 <c:ptCount val="2"/>
                 <c:pt idx="0">
-                  <c:v>코딩
-(평균)</c:v>
+                  <c:v>코딩 (평균)</c:v>
                 </c:pt>
                 <c:pt idx="1">
-                  <c:v>추론
-(평균)</c:v>
+                  <c:v>추론 (평균)</c:v>
                 </c:pt>
               </c:strCache>
             </c:strRef>
@@ -336,12 +330,10 @@
               <c:strCache>
                 <c:ptCount val="2"/>
                 <c:pt idx="0">
-                  <c:v>코딩
-(평균)</c:v>
+                  <c:v>코딩 (평균)</c:v>
                 </c:pt>
                 <c:pt idx="1">
-                  <c:v>추론
-(평균)</c:v>
+                  <c:v>추론 (평균)</c:v>
                 </c:pt>
               </c:strCache>
             </c:strRef>
@@ -380,7 +372,7 @@
           <a:lstStyle/>
           <a:p>
             <a:pPr>
-              <a:defRPr sz="900">
+              <a:defRPr sz="1000">
                 <a:latin typeface="Apple SD Gothic Neo"/>
               </a:defRPr>
             </a:pPr>
@@ -397,7 +389,7 @@
         <c:axId val="-2113994440"/>
         <c:scaling>
           <c:max val="100.0"/>
-          <c:min val="0.0"/>
+          <c:min val="40.0"/>
         </c:scaling>
         <c:delete val="0"/>
         <c:axPos val="l"/>
@@ -410,7 +402,7 @@
           <a:lstStyle/>
           <a:p>
             <a:pPr>
-              <a:defRPr sz="900">
+              <a:defRPr sz="1000">
                 <a:latin typeface="Apple SD Gothic Neo"/>
               </a:defRPr>
             </a:pPr>
@@ -428,13 +420,231 @@
         <a:lstStyle/>
         <a:p>
           <a:pPr>
-            <a:defRPr sz="850">
+            <a:defRPr sz="900">
               <a:latin typeface="Apple SD Gothic Neo"/>
             </a:defRPr>
           </a:pPr>
         </a:p>
       </c:txPr>
     </c:legend>
+    <c:dispBlanksAs val="gap"/>
+  </c:chart>
+  <c:txPr>
+    <a:bodyPr/>
+    <a:lstStyle/>
+    <a:p>
+      <a:pPr>
+        <a:defRPr sz="1800"/>
+      </a:pPr>
+      <a:endParaRPr lang="en-US"/>
+    </a:p>
+  </c:txPr>
+  <c:externalData r:id="rId1">
+    <c:autoUpdate val="0"/>
+  </c:externalData>
+</c:chartSpace>
+</file>
+
+<file path=ppt/charts/chart10.xml><?xml version="1.0" encoding="utf-8"?>
+<c:chartSpace xmlns:c="http://schemas.openxmlformats.org/drawingml/2006/chart" xmlns:a="http://schemas.openxmlformats.org/drawingml/2006/main" xmlns:r="http://schemas.openxmlformats.org/officeDocument/2006/relationships">
+  <c:date1904 val="0"/>
+  <c:chart>
+    <c:title>
+      <c:tx>
+        <c:rich>
+          <a:bodyPr/>
+          <a:lstStyle/>
+          <a:p>
+            <a:pPr>
+              <a:defRPr sz="1150" b="1">
+                <a:solidFill>
+                  <a:srgbClr val="142A4A"/>
+                </a:solidFill>
+                <a:latin typeface="Apple SD Gothic Neo"/>
+              </a:defRPr>
+            </a:pPr>
+            <a:r>
+              <a:t>HLE — 검색·계산 도구 사용</a:t>
+            </a:r>
+          </a:p>
+          <a:p>
+            <a:r>
+              <a:t>도구 쓰면 점수 상승</a:t>
+            </a:r>
+          </a:p>
+        </c:rich>
+      </c:tx>
+      <c:layout/>
+      <c:overlay val="0"/>
+    </c:title>
+    <c:autoTitleDeleted val="0"/>
+    <c:plotArea>
+      <c:barChart>
+        <c:barDir val="bar"/>
+        <c:grouping val="clustered"/>
+        <c:ser>
+          <c:idx val="0"/>
+          <c:order val="0"/>
+          <c:tx>
+            <c:strRef>
+              <c:f>Sheet1!$B$1</c:f>
+              <c:strCache>
+                <c:ptCount val="1"/>
+                <c:pt idx="0">
+                  <c:v/>
+                </c:pt>
+              </c:strCache>
+            </c:strRef>
+          </c:tx>
+          <c:dPt>
+            <c:idx val="0"/>
+            <c:spPr>
+              <a:solidFill>
+                <a:srgbClr val="D4774A"/>
+              </a:solidFill>
+              <a:ln>
+                <a:noFill/>
+              </a:ln>
+            </c:spPr>
+          </c:dPt>
+          <c:dPt>
+            <c:idx val="1"/>
+            <c:spPr>
+              <a:solidFill>
+                <a:srgbClr val="10A37A"/>
+              </a:solidFill>
+              <a:ln>
+                <a:noFill/>
+              </a:ln>
+            </c:spPr>
+          </c:dPt>
+          <c:dPt>
+            <c:idx val="2"/>
+            <c:spPr>
+              <a:solidFill>
+                <a:srgbClr val="4285F4"/>
+              </a:solidFill>
+              <a:ln>
+                <a:noFill/>
+              </a:ln>
+            </c:spPr>
+          </c:dPt>
+          <c:cat>
+            <c:strRef>
+              <c:f>Sheet1!$A$2:$A$4</c:f>
+              <c:strCache>
+                <c:ptCount val="3"/>
+                <c:pt idx="0">
+                  <c:v>Claude</c:v>
+                </c:pt>
+                <c:pt idx="1">
+                  <c:v>GPT-5.5</c:v>
+                </c:pt>
+                <c:pt idx="2">
+                  <c:v>Gemini</c:v>
+                </c:pt>
+              </c:strCache>
+            </c:strRef>
+          </c:cat>
+          <c:val>
+            <c:numRef>
+              <c:f>Sheet1!$B$2:$B$4</c:f>
+              <c:numCache>
+                <c:formatCode>General</c:formatCode>
+                <c:ptCount val="3"/>
+                <c:pt idx="0">
+                  <c:v>57.9</c:v>
+                </c:pt>
+                <c:pt idx="1">
+                  <c:v>52.2</c:v>
+                </c:pt>
+                <c:pt idx="2">
+                  <c:v>51.4</c:v>
+                </c:pt>
+              </c:numCache>
+            </c:numRef>
+          </c:val>
+        </c:ser>
+        <c:dLbls>
+          <c:numFmt formatCode="0.0&quot;%&quot;" sourceLinked="0"/>
+          <c:txPr>
+            <a:bodyPr/>
+            <a:lstStyle/>
+            <a:p>
+              <a:pPr>
+                <a:defRPr sz="1000" b="1">
+                  <a:latin typeface="Apple SD Gothic Neo"/>
+                </a:defRPr>
+              </a:pPr>
+            </a:p>
+          </c:txPr>
+          <c:dLblPos val="outEnd"/>
+          <c:showLegendKey val="0"/>
+          <c:showVal val="1"/>
+          <c:showCatName val="0"/>
+          <c:showSerName val="0"/>
+          <c:showPercent val="0"/>
+          <c:showBubbleSize val="0"/>
+          <c:showLeaderLines val="1"/>
+        </c:dLbls>
+        <c:axId val="-2068027336"/>
+        <c:axId val="-2113994440"/>
+      </c:barChart>
+      <c:catAx>
+        <c:axId val="-2068027336"/>
+        <c:scaling>
+          <c:orientation val="maxMin"/>
+          <c:max val="65.0"/>
+          <c:min val="45.0"/>
+        </c:scaling>
+        <c:delete val="0"/>
+        <c:axPos val="l"/>
+        <c:majorGridlines/>
+        <c:majorTickMark val="out"/>
+        <c:minorTickMark val="none"/>
+        <c:tickLblPos val="nextTo"/>
+        <c:txPr>
+          <a:bodyPr/>
+          <a:lstStyle/>
+          <a:p>
+            <a:pPr>
+              <a:defRPr sz="1000">
+                <a:latin typeface="Apple SD Gothic Neo"/>
+              </a:defRPr>
+            </a:pPr>
+          </a:p>
+        </c:txPr>
+        <c:crossAx val="-2113994440"/>
+        <c:crosses val="autoZero"/>
+        <c:auto val="1"/>
+        <c:lblAlgn val="ctr"/>
+        <c:lblOffset val="100"/>
+        <c:noMultiLvlLbl val="0"/>
+      </c:catAx>
+      <c:valAx>
+        <c:axId val="-2113994440"/>
+        <c:scaling/>
+        <c:delete val="0"/>
+        <c:axPos val="b"/>
+        <c:majorGridlines/>
+        <c:majorTickMark val="out"/>
+        <c:minorTickMark val="none"/>
+        <c:tickLblPos val="nextTo"/>
+        <c:txPr>
+          <a:bodyPr/>
+          <a:lstStyle/>
+          <a:p>
+            <a:pPr>
+              <a:defRPr sz="1000">
+                <a:latin typeface="Apple SD Gothic Neo"/>
+              </a:defRPr>
+            </a:pPr>
+          </a:p>
+        </c:txPr>
+        <c:crossAx val="-2068027336"/>
+        <c:crosses val="autoZero"/>
+      </c:valAx>
+    </c:plotArea>
     <c:dispBlanksAs val="gap"/>
   </c:chart>
   <c:txPr>
@@ -472,7 +682,7 @@
               </a:defRPr>
             </a:pPr>
             <a:r>
-              <a:t>SWE-bench Verified (보통 난이도)</a:t>
+              <a:t>SWE-bench Verified (보통)</a:t>
             </a:r>
           </a:p>
           <a:p>
@@ -554,18 +764,16 @@
               <c:strCache>
                 <c:ptCount val="4"/>
                 <c:pt idx="0">
-                  <c:v>Claude
-Opus 4.8</c:v>
+                  <c:v>Claude</c:v>
                 </c:pt>
                 <c:pt idx="1">
                   <c:v>GPT-5.5</c:v>
                 </c:pt>
                 <c:pt idx="2">
-                  <c:v>Gemini
-3.1 Pro</c:v>
+                  <c:v>Gemini</c:v>
                 </c:pt>
                 <c:pt idx="3">
-                  <c:v>Grok 4.3</c:v>
+                  <c:v>Grok</c:v>
                 </c:pt>
               </c:strCache>
             </c:strRef>
@@ -593,13 +801,13 @@
           </c:val>
         </c:ser>
         <c:dLbls>
-          <c:numFmt formatCode="0&quot;%&quot;" sourceLinked="0"/>
+          <c:numFmt formatCode="0.0&quot;%&quot;" sourceLinked="0"/>
           <c:txPr>
             <a:bodyPr/>
             <a:lstStyle/>
             <a:p>
               <a:pPr>
-                <a:defRPr sz="900">
+                <a:defRPr sz="1000" b="1">
                   <a:latin typeface="Apple SD Gothic Neo"/>
                 </a:defRPr>
               </a:pPr>
@@ -622,7 +830,7 @@
         <c:scaling>
           <c:orientation val="maxMin"/>
           <c:max val="100.0"/>
-          <c:min val="0.0"/>
+          <c:min val="60.0"/>
         </c:scaling>
         <c:delete val="0"/>
         <c:axPos val="l"/>
@@ -635,7 +843,7 @@
           <a:lstStyle/>
           <a:p>
             <a:pPr>
-              <a:defRPr sz="900">
+              <a:defRPr sz="1000">
                 <a:latin typeface="Apple SD Gothic Neo"/>
               </a:defRPr>
             </a:pPr>
@@ -662,7 +870,7 @@
           <a:lstStyle/>
           <a:p>
             <a:pPr>
-              <a:defRPr sz="900">
+              <a:defRPr sz="1000">
                 <a:latin typeface="Apple SD Gothic Neo"/>
               </a:defRPr>
             </a:pPr>
@@ -709,7 +917,7 @@
               </a:defRPr>
             </a:pPr>
             <a:r>
-              <a:t>SWE-bench Pro (어려운 버전)</a:t>
+              <a:t>SWE-bench Pro (어려움)</a:t>
             </a:r>
           </a:p>
           <a:p>
@@ -780,15 +988,13 @@
               <c:strCache>
                 <c:ptCount val="3"/>
                 <c:pt idx="0">
-                  <c:v>Claude
-Opus 4.8</c:v>
+                  <c:v>Claude</c:v>
                 </c:pt>
                 <c:pt idx="1">
                   <c:v>GPT-5.5</c:v>
                 </c:pt>
                 <c:pt idx="2">
-                  <c:v>Gemini
-3.1 Pro</c:v>
+                  <c:v>Gemini</c:v>
                 </c:pt>
               </c:strCache>
             </c:strRef>
@@ -813,13 +1019,13 @@
           </c:val>
         </c:ser>
         <c:dLbls>
-          <c:numFmt formatCode="0&quot;%&quot;" sourceLinked="0"/>
+          <c:numFmt formatCode="0.0&quot;%&quot;" sourceLinked="0"/>
           <c:txPr>
             <a:bodyPr/>
             <a:lstStyle/>
             <a:p>
               <a:pPr>
-                <a:defRPr sz="900">
+                <a:defRPr sz="1000" b="1">
                   <a:latin typeface="Apple SD Gothic Neo"/>
                 </a:defRPr>
               </a:pPr>
@@ -841,8 +1047,8 @@
         <c:axId val="-2068027336"/>
         <c:scaling>
           <c:orientation val="maxMin"/>
-          <c:max val="100.0"/>
-          <c:min val="0.0"/>
+          <c:max val="80.0"/>
+          <c:min val="40.0"/>
         </c:scaling>
         <c:delete val="0"/>
         <c:axPos val="l"/>
@@ -855,7 +1061,7 @@
           <a:lstStyle/>
           <a:p>
             <a:pPr>
-              <a:defRPr sz="900">
+              <a:defRPr sz="1000">
                 <a:latin typeface="Apple SD Gothic Neo"/>
               </a:defRPr>
             </a:pPr>
@@ -882,7 +1088,7 @@
           <a:lstStyle/>
           <a:p>
             <a:pPr>
-              <a:defRPr sz="900">
+              <a:defRPr sz="1000">
                 <a:latin typeface="Apple SD Gothic Neo"/>
               </a:defRPr>
             </a:pPr>
@@ -929,12 +1135,12 @@
               </a:defRPr>
             </a:pPr>
             <a:r>
-              <a:t>Terminal-Bench 2.1 (터미널·명령어)</a:t>
-            </a:r>
-          </a:p>
-          <a:p>
-            <a:r>
-              <a:t>긴 명령 작업 성공률</a:t>
+              <a:t>Terminal-Bench 2.1 (터미널)</a:t>
+            </a:r>
+          </a:p>
+          <a:p>
+            <a:r>
+              <a:t>명령 작업 성공률</a:t>
             </a:r>
           </a:p>
         </c:rich>
@@ -1000,15 +1206,13 @@
               <c:strCache>
                 <c:ptCount val="3"/>
                 <c:pt idx="0">
-                  <c:v>Claude
-Opus 4.8</c:v>
+                  <c:v>Claude</c:v>
                 </c:pt>
                 <c:pt idx="1">
                   <c:v>GPT-5.5</c:v>
                 </c:pt>
                 <c:pt idx="2">
-                  <c:v>Gemini
-3.1 Pro</c:v>
+                  <c:v>Gemini</c:v>
                 </c:pt>
               </c:strCache>
             </c:strRef>
@@ -1033,13 +1237,13 @@
           </c:val>
         </c:ser>
         <c:dLbls>
-          <c:numFmt formatCode="0&quot;%&quot;" sourceLinked="0"/>
+          <c:numFmt formatCode="0.0&quot;%&quot;" sourceLinked="0"/>
           <c:txPr>
             <a:bodyPr/>
             <a:lstStyle/>
             <a:p>
               <a:pPr>
-                <a:defRPr sz="900">
+                <a:defRPr sz="1000" b="1">
                   <a:latin typeface="Apple SD Gothic Neo"/>
                 </a:defRPr>
               </a:pPr>
@@ -1061,8 +1265,8 @@
         <c:axId val="-2068027336"/>
         <c:scaling>
           <c:orientation val="maxMin"/>
-          <c:max val="100.0"/>
-          <c:min val="0.0"/>
+          <c:max val="85.0"/>
+          <c:min val="60.0"/>
         </c:scaling>
         <c:delete val="0"/>
         <c:axPos val="l"/>
@@ -1075,7 +1279,7 @@
           <a:lstStyle/>
           <a:p>
             <a:pPr>
-              <a:defRPr sz="900">
+              <a:defRPr sz="1000">
                 <a:latin typeface="Apple SD Gothic Neo"/>
               </a:defRPr>
             </a:pPr>
@@ -1102,7 +1306,7 @@
           <a:lstStyle/>
           <a:p>
             <a:pPr>
-              <a:defRPr sz="900">
+              <a:defRPr sz="1000">
                 <a:latin typeface="Apple SD Gothic Neo"/>
               </a:defRPr>
             </a:pPr>
@@ -1149,12 +1353,12 @@
               </a:defRPr>
             </a:pPr>
             <a:r>
-              <a:t>OSWorld-Verified (PC 직접 조작)</a:t>
-            </a:r>
-          </a:p>
-          <a:p>
-            <a:r>
-              <a:t>Gemini·Grok * 근사치</a:t>
+              <a:t>OSWorld (PC 직접 조작)</a:t>
+            </a:r>
+          </a:p>
+          <a:p>
+            <a:r>
+              <a:t>Grok 미공개</a:t>
             </a:r>
           </a:p>
         </c:rich>
@@ -1220,15 +1424,13 @@
               <c:strCache>
                 <c:ptCount val="3"/>
                 <c:pt idx="0">
-                  <c:v>Claude
-Opus 4.8</c:v>
+                  <c:v>Claude</c:v>
                 </c:pt>
                 <c:pt idx="1">
                   <c:v>GPT-5.5</c:v>
                 </c:pt>
                 <c:pt idx="2">
-                  <c:v>Gemini
-3.1 Pro</c:v>
+                  <c:v>Gemini</c:v>
                 </c:pt>
               </c:strCache>
             </c:strRef>
@@ -1253,13 +1455,13 @@
           </c:val>
         </c:ser>
         <c:dLbls>
-          <c:numFmt formatCode="0&quot;%&quot;" sourceLinked="0"/>
+          <c:numFmt formatCode="0.0&quot;%&quot;" sourceLinked="0"/>
           <c:txPr>
             <a:bodyPr/>
             <a:lstStyle/>
             <a:p>
               <a:pPr>
-                <a:defRPr sz="900">
+                <a:defRPr sz="1000" b="1">
                   <a:latin typeface="Apple SD Gothic Neo"/>
                 </a:defRPr>
               </a:pPr>
@@ -1281,8 +1483,8 @@
         <c:axId val="-2068027336"/>
         <c:scaling>
           <c:orientation val="maxMin"/>
-          <c:max val="100.0"/>
-          <c:min val="0.0"/>
+          <c:max val="90.0"/>
+          <c:min val="65.0"/>
         </c:scaling>
         <c:delete val="0"/>
         <c:axPos val="l"/>
@@ -1295,7 +1497,7 @@
           <a:lstStyle/>
           <a:p>
             <a:pPr>
-              <a:defRPr sz="900">
+              <a:defRPr sz="1000">
                 <a:latin typeface="Apple SD Gothic Neo"/>
               </a:defRPr>
             </a:pPr>
@@ -1322,7 +1524,7 @@
           <a:lstStyle/>
           <a:p>
             <a:pPr>
-              <a:defRPr sz="900">
+              <a:defRPr sz="1000">
                 <a:latin typeface="Apple SD Gothic Neo"/>
               </a:defRPr>
             </a:pPr>
@@ -1369,7 +1571,7 @@
               </a:defRPr>
             </a:pPr>
             <a:r>
-              <a:t>GPQA Diamond (대학원 과학 퀴즈)</a:t>
+              <a:t>GPQA Diamond (과학 퀴즈)</a:t>
             </a:r>
           </a:p>
           <a:p>
@@ -1451,18 +1653,16 @@
               <c:strCache>
                 <c:ptCount val="4"/>
                 <c:pt idx="0">
-                  <c:v>Claude
-Opus 4.8</c:v>
+                  <c:v>Claude</c:v>
                 </c:pt>
                 <c:pt idx="1">
                   <c:v>GPT-5.5</c:v>
                 </c:pt>
                 <c:pt idx="2">
-                  <c:v>Gemini
-3.1 Pro</c:v>
+                  <c:v>Gemini</c:v>
                 </c:pt>
                 <c:pt idx="3">
-                  <c:v>Grok 4.3</c:v>
+                  <c:v>Grok</c:v>
                 </c:pt>
               </c:strCache>
             </c:strRef>
@@ -1490,13 +1690,13 @@
           </c:val>
         </c:ser>
         <c:dLbls>
-          <c:numFmt formatCode="0&quot;%&quot;" sourceLinked="0"/>
+          <c:numFmt formatCode="0.0&quot;%&quot;" sourceLinked="0"/>
           <c:txPr>
             <a:bodyPr/>
             <a:lstStyle/>
             <a:p>
               <a:pPr>
-                <a:defRPr sz="900">
+                <a:defRPr sz="1000" b="1">
                   <a:latin typeface="Apple SD Gothic Neo"/>
                 </a:defRPr>
               </a:pPr>
@@ -1519,7 +1719,7 @@
         <c:scaling>
           <c:orientation val="maxMin"/>
           <c:max val="100.0"/>
-          <c:min val="0.0"/>
+          <c:min val="80.0"/>
         </c:scaling>
         <c:delete val="0"/>
         <c:axPos val="l"/>
@@ -1532,7 +1732,7 @@
           <a:lstStyle/>
           <a:p>
             <a:pPr>
-              <a:defRPr sz="900">
+              <a:defRPr sz="1000">
                 <a:latin typeface="Apple SD Gothic Neo"/>
               </a:defRPr>
             </a:pPr>
@@ -1559,7 +1759,7 @@
           <a:lstStyle/>
           <a:p>
             <a:pPr>
-              <a:defRPr sz="900">
+              <a:defRPr sz="1000">
                 <a:latin typeface="Apple SD Gothic Neo"/>
               </a:defRPr>
             </a:pPr>
@@ -1606,7 +1806,7 @@
               </a:defRPr>
             </a:pPr>
             <a:r>
-              <a:t>HLE — 도구 없이 혼자 풀기</a:t>
+              <a:t>HLE (도구 없이 혼자 풀기)</a:t>
             </a:r>
           </a:p>
           <a:p>
@@ -1688,18 +1888,16 @@
               <c:strCache>
                 <c:ptCount val="4"/>
                 <c:pt idx="0">
-                  <c:v>Claude
-Opus 4.8</c:v>
+                  <c:v>Claude</c:v>
                 </c:pt>
                 <c:pt idx="1">
                   <c:v>GPT-5.5</c:v>
                 </c:pt>
                 <c:pt idx="2">
-                  <c:v>Gemini
-3.1 Pro</c:v>
+                  <c:v>Gemini</c:v>
                 </c:pt>
                 <c:pt idx="3">
-                  <c:v>Grok 4.3</c:v>
+                  <c:v>Grok</c:v>
                 </c:pt>
               </c:strCache>
             </c:strRef>
@@ -1727,13 +1925,13 @@
           </c:val>
         </c:ser>
         <c:dLbls>
-          <c:numFmt formatCode="0&quot;%&quot;" sourceLinked="0"/>
+          <c:numFmt formatCode="0.0&quot;%&quot;" sourceLinked="0"/>
           <c:txPr>
             <a:bodyPr/>
             <a:lstStyle/>
             <a:p>
               <a:pPr>
-                <a:defRPr sz="900">
+                <a:defRPr sz="1000" b="1">
                   <a:latin typeface="Apple SD Gothic Neo"/>
                 </a:defRPr>
               </a:pPr>
@@ -1755,8 +1953,8 @@
         <c:axId val="-2068027336"/>
         <c:scaling>
           <c:orientation val="maxMin"/>
-          <c:max val="100.0"/>
-          <c:min val="0.0"/>
+          <c:max val="60.0"/>
+          <c:min val="30.0"/>
         </c:scaling>
         <c:delete val="0"/>
         <c:axPos val="l"/>
@@ -1769,7 +1967,7 @@
           <a:lstStyle/>
           <a:p>
             <a:pPr>
-              <a:defRPr sz="900">
+              <a:defRPr sz="1000">
                 <a:latin typeface="Apple SD Gothic Neo"/>
               </a:defRPr>
             </a:pPr>
@@ -1796,7 +1994,7 @@
           <a:lstStyle/>
           <a:p>
             <a:pPr>
-              <a:defRPr sz="900">
+              <a:defRPr sz="1000">
                 <a:latin typeface="Apple SD Gothic Neo"/>
               </a:defRPr>
             </a:pPr>
@@ -1843,7 +2041,7 @@
               </a:defRPr>
             </a:pPr>
             <a:r>
-              <a:t>수학 시험 3종 비교 — 막대가 길수록 정답률 높음 (%)</a:t>
+              <a:t>기본·올림피아드 수학 (%)</a:t>
             </a:r>
           </a:p>
         </c:rich>
@@ -1865,7 +2063,7 @@
               <c:strCache>
                 <c:ptCount val="1"/>
                 <c:pt idx="0">
-                  <c:v>MATH-500 (기본~중급)</c:v>
+                  <c:v>MATH-500</c:v>
                 </c:pt>
               </c:strCache>
             </c:strRef>
@@ -1884,18 +2082,16 @@
               <c:strCache>
                 <c:ptCount val="4"/>
                 <c:pt idx="0">
-                  <c:v>Claude
-Opus 4.8</c:v>
+                  <c:v>Claude</c:v>
                 </c:pt>
                 <c:pt idx="1">
                   <c:v>GPT-5.5</c:v>
                 </c:pt>
                 <c:pt idx="2">
-                  <c:v>Gemini
-3.1 Pro</c:v>
+                  <c:v>Gemini</c:v>
                 </c:pt>
                 <c:pt idx="3">
-                  <c:v>Grok 4.3</c:v>
+                  <c:v>Grok</c:v>
                 </c:pt>
               </c:strCache>
             </c:strRef>
@@ -1931,7 +2127,7 @@
               <c:strCache>
                 <c:ptCount val="1"/>
                 <c:pt idx="0">
-                  <c:v>AIME 2026 (올림피아드급)</c:v>
+                  <c:v>AIME 2026</c:v>
                 </c:pt>
               </c:strCache>
             </c:strRef>
@@ -1950,18 +2146,16 @@
               <c:strCache>
                 <c:ptCount val="4"/>
                 <c:pt idx="0">
-                  <c:v>Claude
-Opus 4.8</c:v>
+                  <c:v>Claude</c:v>
                 </c:pt>
                 <c:pt idx="1">
                   <c:v>GPT-5.5</c:v>
                 </c:pt>
                 <c:pt idx="2">
-                  <c:v>Gemini
-3.1 Pro</c:v>
+                  <c:v>Gemini</c:v>
                 </c:pt>
                 <c:pt idx="3">
-                  <c:v>Grok 4.3</c:v>
+                  <c:v>Grok</c:v>
                 </c:pt>
               </c:strCache>
             </c:strRef>
@@ -1988,23 +2182,146 @@
             </c:numRef>
           </c:val>
         </c:ser>
+        <c:axId val="-2068027336"/>
+        <c:axId val="-2113994440"/>
+      </c:barChart>
+      <c:catAx>
+        <c:axId val="-2068027336"/>
+        <c:scaling>
+          <c:orientation val="minMax"/>
+        </c:scaling>
+        <c:delete val="0"/>
+        <c:axPos val="b"/>
+        <c:majorTickMark val="out"/>
+        <c:minorTickMark val="none"/>
+        <c:tickLblPos val="nextTo"/>
+        <c:txPr>
+          <a:bodyPr/>
+          <a:lstStyle/>
+          <a:p>
+            <a:pPr>
+              <a:defRPr sz="1000">
+                <a:latin typeface="Apple SD Gothic Neo"/>
+              </a:defRPr>
+            </a:pPr>
+          </a:p>
+        </c:txPr>
+        <c:crossAx val="-2113994440"/>
+        <c:crosses val="autoZero"/>
+        <c:auto val="1"/>
+        <c:lblAlgn val="ctr"/>
+        <c:lblOffset val="100"/>
+        <c:noMultiLvlLbl val="0"/>
+      </c:catAx>
+      <c:valAx>
+        <c:axId val="-2113994440"/>
+        <c:scaling>
+          <c:max val="100.0"/>
+          <c:min val="90.0"/>
+        </c:scaling>
+        <c:delete val="0"/>
+        <c:axPos val="l"/>
+        <c:majorGridlines/>
+        <c:majorTickMark val="out"/>
+        <c:minorTickMark val="none"/>
+        <c:tickLblPos val="nextTo"/>
+        <c:txPr>
+          <a:bodyPr/>
+          <a:lstStyle/>
+          <a:p>
+            <a:pPr>
+              <a:defRPr sz="1000">
+                <a:latin typeface="Apple SD Gothic Neo"/>
+              </a:defRPr>
+            </a:pPr>
+          </a:p>
+        </c:txPr>
+        <c:crossAx val="-2068027336"/>
+        <c:crosses val="autoZero"/>
+      </c:valAx>
+    </c:plotArea>
+    <c:legend>
+      <c:legendPos val="b"/>
+      <c:overlay val="0"/>
+      <c:txPr>
+        <a:bodyPr/>
+        <a:lstStyle/>
+        <a:p>
+          <a:pPr>
+            <a:defRPr sz="900">
+              <a:latin typeface="Apple SD Gothic Neo"/>
+            </a:defRPr>
+          </a:pPr>
+        </a:p>
+      </c:txPr>
+    </c:legend>
+    <c:dispBlanksAs val="gap"/>
+  </c:chart>
+  <c:txPr>
+    <a:bodyPr/>
+    <a:lstStyle/>
+    <a:p>
+      <a:pPr>
+        <a:defRPr sz="1800"/>
+      </a:pPr>
+      <a:endParaRPr lang="en-US"/>
+    </a:p>
+  </c:txPr>
+  <c:externalData r:id="rId1">
+    <c:autoUpdate val="0"/>
+  </c:externalData>
+</c:chartSpace>
+</file>
+
+<file path=ppt/charts/chart9.xml><?xml version="1.0" encoding="utf-8"?>
+<c:chartSpace xmlns:c="http://schemas.openxmlformats.org/drawingml/2006/chart" xmlns:a="http://schemas.openxmlformats.org/drawingml/2006/main" xmlns:r="http://schemas.openxmlformats.org/officeDocument/2006/relationships">
+  <c:date1904 val="0"/>
+  <c:chart>
+    <c:title>
+      <c:tx>
+        <c:rich>
+          <a:bodyPr/>
+          <a:lstStyle/>
+          <a:p>
+            <a:pPr>
+              <a:defRPr sz="1200" b="1">
+                <a:solidFill>
+                  <a:srgbClr val="142A4A"/>
+                </a:solidFill>
+                <a:latin typeface="Apple SD Gothic Neo"/>
+              </a:defRPr>
+            </a:pPr>
+            <a:r>
+              <a:t>최고난도 수학 (%)</a:t>
+            </a:r>
+          </a:p>
+        </c:rich>
+      </c:tx>
+      <c:layout/>
+      <c:overlay val="0"/>
+    </c:title>
+    <c:autoTitleDeleted val="0"/>
+    <c:plotArea>
+      <c:barChart>
+        <c:barDir val="col"/>
+        <c:grouping val="clustered"/>
         <c:ser>
-          <c:idx val="2"/>
-          <c:order val="2"/>
+          <c:idx val="0"/>
+          <c:order val="0"/>
           <c:tx>
             <c:strRef>
-              <c:f>Sheet1!$D$1</c:f>
+              <c:f>Sheet1!$B$1</c:f>
               <c:strCache>
                 <c:ptCount val="1"/>
                 <c:pt idx="0">
-                  <c:v>FrontierMath (최고난도)</c:v>
+                  <c:v>FrontierMath</c:v>
                 </c:pt>
               </c:strCache>
             </c:strRef>
           </c:tx>
           <c:spPr>
             <a:solidFill>
-              <a:srgbClr val="F27E2E"/>
+              <a:srgbClr val="1F6FB2"/>
             </a:solidFill>
             <a:ln>
               <a:noFill/>
@@ -2016,25 +2333,23 @@
               <c:strCache>
                 <c:ptCount val="4"/>
                 <c:pt idx="0">
-                  <c:v>Claude
-Opus 4.8</c:v>
+                  <c:v>Claude</c:v>
                 </c:pt>
                 <c:pt idx="1">
                   <c:v>GPT-5.5</c:v>
                 </c:pt>
                 <c:pt idx="2">
-                  <c:v>Gemini
-3.1 Pro</c:v>
+                  <c:v>Gemini</c:v>
                 </c:pt>
                 <c:pt idx="3">
-                  <c:v>Grok 4.3</c:v>
+                  <c:v>Grok</c:v>
                 </c:pt>
               </c:strCache>
             </c:strRef>
           </c:cat>
           <c:val>
             <c:numRef>
-              <c:f>Sheet1!$D$2:$D$5</c:f>
+              <c:f>Sheet1!$B$2:$B$5</c:f>
               <c:numCache>
                 <c:formatCode>General</c:formatCode>
                 <c:ptCount val="4"/>
@@ -2072,7 +2387,7 @@
           <a:lstStyle/>
           <a:p>
             <a:pPr>
-              <a:defRPr sz="900">
+              <a:defRPr sz="1000">
                 <a:latin typeface="Apple SD Gothic Neo"/>
               </a:defRPr>
             </a:pPr>
@@ -2088,8 +2403,8 @@
       <c:valAx>
         <c:axId val="-2113994440"/>
         <c:scaling>
-          <c:max val="100.0"/>
-          <c:min val="0.0"/>
+          <c:max val="60.0"/>
+          <c:min val="40.0"/>
         </c:scaling>
         <c:delete val="0"/>
         <c:axPos val="l"/>
@@ -2102,7 +2417,7 @@
           <a:lstStyle/>
           <a:p>
             <a:pPr>
-              <a:defRPr sz="900">
+              <a:defRPr sz="1000">
                 <a:latin typeface="Apple SD Gothic Neo"/>
               </a:defRPr>
             </a:pPr>
@@ -2120,233 +2435,13 @@
         <a:lstStyle/>
         <a:p>
           <a:pPr>
-            <a:defRPr sz="850">
+            <a:defRPr sz="900">
               <a:latin typeface="Apple SD Gothic Neo"/>
             </a:defRPr>
           </a:pPr>
         </a:p>
       </c:txPr>
     </c:legend>
-    <c:dispBlanksAs val="gap"/>
-  </c:chart>
-  <c:txPr>
-    <a:bodyPr/>
-    <a:lstStyle/>
-    <a:p>
-      <a:pPr>
-        <a:defRPr sz="1800"/>
-      </a:pPr>
-      <a:endParaRPr lang="en-US"/>
-    </a:p>
-  </c:txPr>
-  <c:externalData r:id="rId1">
-    <c:autoUpdate val="0"/>
-  </c:externalData>
-</c:chartSpace>
-</file>
-
-<file path=ppt/charts/chart9.xml><?xml version="1.0" encoding="utf-8"?>
-<c:chartSpace xmlns:c="http://schemas.openxmlformats.org/drawingml/2006/chart" xmlns:a="http://schemas.openxmlformats.org/drawingml/2006/main" xmlns:r="http://schemas.openxmlformats.org/officeDocument/2006/relationships">
-  <c:date1904 val="0"/>
-  <c:chart>
-    <c:title>
-      <c:tx>
-        <c:rich>
-          <a:bodyPr/>
-          <a:lstStyle/>
-          <a:p>
-            <a:pPr>
-              <a:defRPr sz="1150" b="1">
-                <a:solidFill>
-                  <a:srgbClr val="142A4A"/>
-                </a:solidFill>
-                <a:latin typeface="Apple SD Gothic Neo"/>
-              </a:defRPr>
-            </a:pPr>
-            <a:r>
-              <a:t>HLE — 검색·계산 도구 사용 가능</a:t>
-            </a:r>
-          </a:p>
-          <a:p>
-            <a:r>
-              <a:t>도구 쓰면 점수 상승</a:t>
-            </a:r>
-          </a:p>
-        </c:rich>
-      </c:tx>
-      <c:layout/>
-      <c:overlay val="0"/>
-    </c:title>
-    <c:autoTitleDeleted val="0"/>
-    <c:plotArea>
-      <c:barChart>
-        <c:barDir val="bar"/>
-        <c:grouping val="clustered"/>
-        <c:ser>
-          <c:idx val="0"/>
-          <c:order val="0"/>
-          <c:tx>
-            <c:strRef>
-              <c:f>Sheet1!$B$1</c:f>
-              <c:strCache>
-                <c:ptCount val="1"/>
-                <c:pt idx="0">
-                  <c:v/>
-                </c:pt>
-              </c:strCache>
-            </c:strRef>
-          </c:tx>
-          <c:dPt>
-            <c:idx val="0"/>
-            <c:spPr>
-              <a:solidFill>
-                <a:srgbClr val="D4774A"/>
-              </a:solidFill>
-              <a:ln>
-                <a:noFill/>
-              </a:ln>
-            </c:spPr>
-          </c:dPt>
-          <c:dPt>
-            <c:idx val="1"/>
-            <c:spPr>
-              <a:solidFill>
-                <a:srgbClr val="10A37A"/>
-              </a:solidFill>
-              <a:ln>
-                <a:noFill/>
-              </a:ln>
-            </c:spPr>
-          </c:dPt>
-          <c:dPt>
-            <c:idx val="2"/>
-            <c:spPr>
-              <a:solidFill>
-                <a:srgbClr val="4285F4"/>
-              </a:solidFill>
-              <a:ln>
-                <a:noFill/>
-              </a:ln>
-            </c:spPr>
-          </c:dPt>
-          <c:cat>
-            <c:strRef>
-              <c:f>Sheet1!$A$2:$A$4</c:f>
-              <c:strCache>
-                <c:ptCount val="3"/>
-                <c:pt idx="0">
-                  <c:v>Claude
-Opus 4.8</c:v>
-                </c:pt>
-                <c:pt idx="1">
-                  <c:v>GPT-5.5</c:v>
-                </c:pt>
-                <c:pt idx="2">
-                  <c:v>Gemini
-3.1 Pro</c:v>
-                </c:pt>
-              </c:strCache>
-            </c:strRef>
-          </c:cat>
-          <c:val>
-            <c:numRef>
-              <c:f>Sheet1!$B$2:$B$4</c:f>
-              <c:numCache>
-                <c:formatCode>General</c:formatCode>
-                <c:ptCount val="3"/>
-                <c:pt idx="0">
-                  <c:v>57.9</c:v>
-                </c:pt>
-                <c:pt idx="1">
-                  <c:v>52.2</c:v>
-                </c:pt>
-                <c:pt idx="2">
-                  <c:v>51.4</c:v>
-                </c:pt>
-              </c:numCache>
-            </c:numRef>
-          </c:val>
-        </c:ser>
-        <c:dLbls>
-          <c:numFmt formatCode="0&quot;%&quot;" sourceLinked="0"/>
-          <c:txPr>
-            <a:bodyPr/>
-            <a:lstStyle/>
-            <a:p>
-              <a:pPr>
-                <a:defRPr sz="900">
-                  <a:latin typeface="Apple SD Gothic Neo"/>
-                </a:defRPr>
-              </a:pPr>
-            </a:p>
-          </c:txPr>
-          <c:dLblPos val="outEnd"/>
-          <c:showLegendKey val="0"/>
-          <c:showVal val="1"/>
-          <c:showCatName val="0"/>
-          <c:showSerName val="0"/>
-          <c:showPercent val="0"/>
-          <c:showBubbleSize val="0"/>
-          <c:showLeaderLines val="1"/>
-        </c:dLbls>
-        <c:axId val="-2068027336"/>
-        <c:axId val="-2113994440"/>
-      </c:barChart>
-      <c:catAx>
-        <c:axId val="-2068027336"/>
-        <c:scaling>
-          <c:orientation val="maxMin"/>
-          <c:max val="100.0"/>
-          <c:min val="0.0"/>
-        </c:scaling>
-        <c:delete val="0"/>
-        <c:axPos val="l"/>
-        <c:majorGridlines/>
-        <c:majorTickMark val="out"/>
-        <c:minorTickMark val="none"/>
-        <c:tickLblPos val="nextTo"/>
-        <c:txPr>
-          <a:bodyPr/>
-          <a:lstStyle/>
-          <a:p>
-            <a:pPr>
-              <a:defRPr sz="900">
-                <a:latin typeface="Apple SD Gothic Neo"/>
-              </a:defRPr>
-            </a:pPr>
-          </a:p>
-        </c:txPr>
-        <c:crossAx val="-2113994440"/>
-        <c:crosses val="autoZero"/>
-        <c:auto val="1"/>
-        <c:lblAlgn val="ctr"/>
-        <c:lblOffset val="100"/>
-        <c:noMultiLvlLbl val="0"/>
-      </c:catAx>
-      <c:valAx>
-        <c:axId val="-2113994440"/>
-        <c:scaling/>
-        <c:delete val="0"/>
-        <c:axPos val="b"/>
-        <c:majorGridlines/>
-        <c:majorTickMark val="out"/>
-        <c:minorTickMark val="none"/>
-        <c:tickLblPos val="nextTo"/>
-        <c:txPr>
-          <a:bodyPr/>
-          <a:lstStyle/>
-          <a:p>
-            <a:pPr>
-              <a:defRPr sz="900">
-                <a:latin typeface="Apple SD Gothic Neo"/>
-              </a:defRPr>
-            </a:pPr>
-          </a:p>
-        </c:txPr>
-        <c:crossAx val="-2068027336"/>
-        <c:crosses val="autoZero"/>
-      </c:valAx>
-    </c:plotArea>
     <c:dispBlanksAs val="gap"/>
   </c:chart>
   <c:txPr>
@@ -5551,6 +5646,48 @@
         </p:nvSpPr>
         <p:spPr>
           <a:xfrm>
+            <a:off x="457200" y="6327648"/>
+            <a:ext cx="10515600" cy="201168"/>
+          </a:xfrm>
+          <a:prstGeom prst="rect">
+            <a:avLst/>
+          </a:prstGeom>
+          <a:noFill/>
+        </p:spPr>
+        <p:txBody>
+          <a:bodyPr wrap="square" anchor="t" lIns="25400" rIns="25400" tIns="25400" bIns="25400">
+            <a:spAutoFit/>
+          </a:bodyPr>
+          <a:lstStyle/>
+          <a:p>
+            <a:pPr algn="l">
+              <a:lnSpc>
+                <a:spcPct val="100000"/>
+              </a:lnSpc>
+              <a:spcAft>
+                <a:spcPts val="400"/>
+              </a:spcAft>
+            </a:pPr>
+            <a:r>
+              <a:rPr sz="850" b="0">
+                <a:solidFill>
+                  <a:srgbClr val="8A929E"/>
+                </a:solidFill>
+                <a:latin typeface="Apple SD Gothic Neo"/>
+              </a:rPr>
+              <a:t>출처: Anthropic · OpenAI · Google · xAI 공식 Model Card + Vellum · Artificial Analysis 독립검증</a:t>
+            </a:r>
+          </a:p>
+        </p:txBody>
+      </p:sp>
+      <p:sp>
+        <p:nvSpPr>
+          <p:cNvPr id="7" name="TextBox 6"/>
+          <p:cNvSpPr txBox="1"/>
+          <p:nvPr/>
+        </p:nvSpPr>
+        <p:spPr>
+          <a:xfrm>
             <a:off x="11338560" y="6492240"/>
             <a:ext cx="731520" cy="274320"/>
           </a:xfrm>
@@ -6202,7 +6339,7 @@
               </a:spcAft>
             </a:pPr>
             <a:r>
-              <a:rPr sz="950" b="0">
+              <a:rPr sz="1000" b="0">
                 <a:solidFill>
                   <a:srgbClr val="444A55"/>
                 </a:solidFill>
@@ -6221,7 +6358,7 @@
         </p:nvSpPr>
         <p:spPr>
           <a:xfrm>
-            <a:off x="1783080" y="2487168"/>
+            <a:off x="1828800" y="2487168"/>
             <a:ext cx="146304" cy="146304"/>
           </a:xfrm>
           <a:prstGeom prst="rect">
@@ -6265,7 +6402,7 @@
         </p:nvSpPr>
         <p:spPr>
           <a:xfrm>
-            <a:off x="1984248" y="2474468"/>
+            <a:off x="2029968" y="2474468"/>
             <a:ext cx="1097280" cy="182880"/>
           </a:xfrm>
           <a:prstGeom prst="rect">
@@ -6288,7 +6425,7 @@
               </a:spcAft>
             </a:pPr>
             <a:r>
-              <a:rPr sz="950" b="0">
+              <a:rPr sz="1000" b="0">
                 <a:solidFill>
                   <a:srgbClr val="444A55"/>
                 </a:solidFill>
@@ -6307,7 +6444,7 @@
         </p:nvSpPr>
         <p:spPr>
           <a:xfrm>
-            <a:off x="3108960" y="2487168"/>
+            <a:off x="3200400" y="2487168"/>
             <a:ext cx="146304" cy="146304"/>
           </a:xfrm>
           <a:prstGeom prst="rect">
@@ -6351,7 +6488,7 @@
         </p:nvSpPr>
         <p:spPr>
           <a:xfrm>
-            <a:off x="3310128" y="2474468"/>
+            <a:off x="3401568" y="2474468"/>
             <a:ext cx="1097280" cy="182880"/>
           </a:xfrm>
           <a:prstGeom prst="rect">
@@ -6374,7 +6511,7 @@
               </a:spcAft>
             </a:pPr>
             <a:r>
-              <a:rPr sz="950" b="0">
+              <a:rPr sz="1000" b="0">
                 <a:solidFill>
                   <a:srgbClr val="444A55"/>
                 </a:solidFill>
@@ -6393,7 +6530,7 @@
         </p:nvSpPr>
         <p:spPr>
           <a:xfrm>
-            <a:off x="4434840" y="2487168"/>
+            <a:off x="4572000" y="2487168"/>
             <a:ext cx="146304" cy="146304"/>
           </a:xfrm>
           <a:prstGeom prst="rect">
@@ -6437,7 +6574,7 @@
         </p:nvSpPr>
         <p:spPr>
           <a:xfrm>
-            <a:off x="4636008" y="2474468"/>
+            <a:off x="4773168" y="2474468"/>
             <a:ext cx="1097280" cy="182880"/>
           </a:xfrm>
           <a:prstGeom prst="rect">
@@ -6460,7 +6597,7 @@
               </a:spcAft>
             </a:pPr>
             <a:r>
-              <a:rPr sz="950" b="0">
+              <a:rPr sz="1000" b="0">
                 <a:solidFill>
                   <a:srgbClr val="444A55"/>
                 </a:solidFill>
@@ -6540,7 +6677,7 @@
         <p:spPr>
           <a:xfrm>
             <a:off x="457200" y="5650992"/>
-            <a:ext cx="11292840" cy="804672"/>
+            <a:ext cx="11292840" cy="594360"/>
           </a:xfrm>
           <a:prstGeom prst="roundRect">
             <a:avLst/>
@@ -6584,7 +6721,7 @@
         <p:spPr>
           <a:xfrm>
             <a:off x="640080" y="5650992"/>
-            <a:ext cx="10927080" cy="804672"/>
+            <a:ext cx="10927080" cy="594360"/>
           </a:xfrm>
           <a:prstGeom prst="rect">
             <a:avLst/>
@@ -6634,30 +6771,53 @@
               <a:t>코딩 = 코드·명령어 잘 다루는지  |  추론 = 머리 쓰는 문제·수학·과학 잘 푸는지</a:t>
             </a:r>
           </a:p>
+        </p:txBody>
+      </p:sp>
+      <p:sp>
+        <p:nvSpPr>
+          <p:cNvPr id="25" name="TextBox 24"/>
+          <p:cNvSpPr txBox="1"/>
+          <p:nvPr/>
+        </p:nvSpPr>
+        <p:spPr>
+          <a:xfrm>
+            <a:off x="457200" y="6327648"/>
+            <a:ext cx="10515600" cy="201168"/>
+          </a:xfrm>
+          <a:prstGeom prst="rect">
+            <a:avLst/>
+          </a:prstGeom>
+          <a:noFill/>
+        </p:spPr>
+        <p:txBody>
+          <a:bodyPr wrap="square" anchor="t" lIns="25400" rIns="25400" tIns="25400" bIns="25400">
+            <a:spAutoFit/>
+          </a:bodyPr>
+          <a:lstStyle/>
           <a:p>
             <a:pPr algn="l">
               <a:lnSpc>
-                <a:spcPct val="115000"/>
+                <a:spcPct val="100000"/>
               </a:lnSpc>
               <a:spcAft>
-                <a:spcPts val="200"/>
+                <a:spcPts val="400"/>
               </a:spcAft>
             </a:pPr>
             <a:r>
-              <a:rPr sz="1100" b="0">
-                <a:solidFill>
-                  <a:srgbClr val="FFFFFF"/>
+              <a:rPr sz="850" b="0">
+                <a:solidFill>
+                  <a:srgbClr val="8A929E"/>
                 </a:solidFill>
                 <a:latin typeface="Apple SD Gothic Neo"/>
               </a:rPr>
-              <a:t>한 AI가 모든 시험 1등은 아님 → 우리 팀 업무에 맞는 시험 점수를 보면 됨</a:t>
-            </a:r>
-          </a:p>
-        </p:txBody>
-      </p:sp>
-      <p:sp>
-        <p:nvSpPr>
-          <p:cNvPr id="25" name="TextBox 24"/>
+              <a:t>출처: 각 사 공식 System Card 평균치 산출</a:t>
+            </a:r>
+          </a:p>
+        </p:txBody>
+      </p:sp>
+      <p:sp>
+        <p:nvSpPr>
+          <p:cNvPr id="26" name="TextBox 25"/>
           <p:cNvSpPr txBox="1"/>
           <p:nvPr/>
         </p:nvSpPr>
@@ -7001,7 +7161,7 @@
         <p:spPr>
           <a:xfrm>
             <a:off x="457200" y="5074920"/>
-            <a:ext cx="11292840" cy="960120"/>
+            <a:ext cx="11292840" cy="914400"/>
           </a:xfrm>
           <a:prstGeom prst="roundRect">
             <a:avLst/>
@@ -7045,7 +7205,7 @@
         <p:spPr>
           <a:xfrm>
             <a:off x="640080" y="5074920"/>
-            <a:ext cx="10927080" cy="960120"/>
+            <a:ext cx="10927080" cy="914400"/>
           </a:xfrm>
           <a:prstGeom prst="rect">
             <a:avLst/>
@@ -7111,7 +7271,7 @@
                 </a:solidFill>
                 <a:latin typeface="Apple SD Gothic Neo"/>
               </a:rPr>
-              <a:t>GPT·Gemini도 50% 넘음 = 쓸 만한 수준  |  실무 코드 수정은 Claude가 가장 유리</a:t>
+              <a:t>GPT·Gemini도 50% 넘음 = 쓸 만한 수준</a:t>
             </a:r>
           </a:p>
         </p:txBody>
@@ -7119,6 +7279,48 @@
       <p:sp>
         <p:nvSpPr>
           <p:cNvPr id="11" name="TextBox 10"/>
+          <p:cNvSpPr txBox="1"/>
+          <p:nvPr/>
+        </p:nvSpPr>
+        <p:spPr>
+          <a:xfrm>
+            <a:off x="457200" y="6327648"/>
+            <a:ext cx="10515600" cy="201168"/>
+          </a:xfrm>
+          <a:prstGeom prst="rect">
+            <a:avLst/>
+          </a:prstGeom>
+          <a:noFill/>
+        </p:spPr>
+        <p:txBody>
+          <a:bodyPr wrap="square" anchor="t" lIns="25400" rIns="25400" tIns="25400" bIns="25400">
+            <a:spAutoFit/>
+          </a:bodyPr>
+          <a:lstStyle/>
+          <a:p>
+            <a:pPr algn="l">
+              <a:lnSpc>
+                <a:spcPct val="100000"/>
+              </a:lnSpc>
+              <a:spcAft>
+                <a:spcPts val="400"/>
+              </a:spcAft>
+            </a:pPr>
+            <a:r>
+              <a:rPr sz="850" b="0">
+                <a:solidFill>
+                  <a:srgbClr val="8A929E"/>
+                </a:solidFill>
+                <a:latin typeface="Apple SD Gothic Neo"/>
+              </a:rPr>
+              <a:t>출처: Anthropic System Card (2026.5) · OpenAI · Google 공식 발표</a:t>
+            </a:r>
+          </a:p>
+        </p:txBody>
+      </p:sp>
+      <p:sp>
+        <p:nvSpPr>
+          <p:cNvPr id="12" name="TextBox 11"/>
           <p:cNvSpPr txBox="1"/>
           <p:nvPr/>
         </p:nvSpPr>
@@ -7462,7 +7664,7 @@
         <p:spPr>
           <a:xfrm>
             <a:off x="457200" y="5074920"/>
-            <a:ext cx="11292840" cy="960120"/>
+            <a:ext cx="11292840" cy="914400"/>
           </a:xfrm>
           <a:prstGeom prst="roundRect">
             <a:avLst/>
@@ -7506,7 +7708,7 @@
         <p:spPr>
           <a:xfrm>
             <a:off x="640080" y="5074920"/>
-            <a:ext cx="10927080" cy="960120"/>
+            <a:ext cx="10927080" cy="914400"/>
           </a:xfrm>
           <a:prstGeom prst="rect">
             <a:avLst/>
@@ -7572,7 +7774,7 @@
                 </a:solidFill>
                 <a:latin typeface="Apple SD Gothic Neo"/>
               </a:rPr>
-              <a:t>PC 화면 직접 조작 → Claude 1위 (83.4%)  |  HW팀: 터미널·자동화는 GPT, GUI 작업은 Claude</a:t>
+              <a:t>PC 화면 직접 조작 → Claude 1위 (83.4%)</a:t>
             </a:r>
           </a:p>
         </p:txBody>
@@ -7580,6 +7782,48 @@
       <p:sp>
         <p:nvSpPr>
           <p:cNvPr id="11" name="TextBox 10"/>
+          <p:cNvSpPr txBox="1"/>
+          <p:nvPr/>
+        </p:nvSpPr>
+        <p:spPr>
+          <a:xfrm>
+            <a:off x="457200" y="6327648"/>
+            <a:ext cx="10515600" cy="201168"/>
+          </a:xfrm>
+          <a:prstGeom prst="rect">
+            <a:avLst/>
+          </a:prstGeom>
+          <a:noFill/>
+        </p:spPr>
+        <p:txBody>
+          <a:bodyPr wrap="square" anchor="t" lIns="25400" rIns="25400" tIns="25400" bIns="25400">
+            <a:spAutoFit/>
+          </a:bodyPr>
+          <a:lstStyle/>
+          <a:p>
+            <a:pPr algn="l">
+              <a:lnSpc>
+                <a:spcPct val="100000"/>
+              </a:lnSpc>
+              <a:spcAft>
+                <a:spcPts val="400"/>
+              </a:spcAft>
+            </a:pPr>
+            <a:r>
+              <a:rPr sz="850" b="0">
+                <a:solidFill>
+                  <a:srgbClr val="8A929E"/>
+                </a:solidFill>
+                <a:latin typeface="Apple SD Gothic Neo"/>
+              </a:rPr>
+              <a:t>출처: Anthropic System Card · HundredTabs 벤치마크 비교 (2026.5)</a:t>
+            </a:r>
+          </a:p>
+        </p:txBody>
+      </p:sp>
+      <p:sp>
+        <p:nvSpPr>
+          <p:cNvPr id="12" name="TextBox 11"/>
           <p:cNvSpPr txBox="1"/>
           <p:nvPr/>
         </p:nvSpPr>
@@ -7923,7 +8167,7 @@
         <p:spPr>
           <a:xfrm>
             <a:off x="457200" y="5074920"/>
-            <a:ext cx="11292840" cy="960120"/>
+            <a:ext cx="11292840" cy="914400"/>
           </a:xfrm>
           <a:prstGeom prst="roundRect">
             <a:avLst/>
@@ -7967,7 +8211,7 @@
         <p:spPr>
           <a:xfrm>
             <a:off x="640080" y="5074920"/>
-            <a:ext cx="10927080" cy="960120"/>
+            <a:ext cx="10927080" cy="914400"/>
           </a:xfrm>
           <a:prstGeom prst="rect">
             <a:avLst/>
@@ -8014,7 +8258,7 @@
                 </a:solidFill>
                 <a:latin typeface="Apple SD Gothic Neo"/>
               </a:rPr>
-              <a:t>과학 퀴즈(GPQA)는 4종 모두 88~94% — 격차 작음 (거의 비슷)</a:t>
+              <a:t>과학 퀴즈(GPQA)는 4종 모두 88~94% — 격차 작음</a:t>
             </a:r>
           </a:p>
           <a:p>
@@ -8033,7 +8277,7 @@
                 </a:solidFill>
                 <a:latin typeface="Apple SD Gothic Neo"/>
               </a:rPr>
-              <a:t>진짜 어려운 생각(HLE)에서는 Claude·Grok 상위 — '막히는 문제'는 Claude가 유리</a:t>
+              <a:t>진짜 어려운 생각(HLE)에서는 Claude·Grok 상위</a:t>
             </a:r>
           </a:p>
         </p:txBody>
@@ -8041,6 +8285,48 @@
       <p:sp>
         <p:nvSpPr>
           <p:cNvPr id="11" name="TextBox 10"/>
+          <p:cNvSpPr txBox="1"/>
+          <p:nvPr/>
+        </p:nvSpPr>
+        <p:spPr>
+          <a:xfrm>
+            <a:off x="457200" y="6327648"/>
+            <a:ext cx="10515600" cy="201168"/>
+          </a:xfrm>
+          <a:prstGeom prst="rect">
+            <a:avLst/>
+          </a:prstGeom>
+          <a:noFill/>
+        </p:spPr>
+        <p:txBody>
+          <a:bodyPr wrap="square" anchor="t" lIns="25400" rIns="25400" tIns="25400" bIns="25400">
+            <a:spAutoFit/>
+          </a:bodyPr>
+          <a:lstStyle/>
+          <a:p>
+            <a:pPr algn="l">
+              <a:lnSpc>
+                <a:spcPct val="100000"/>
+              </a:lnSpc>
+              <a:spcAft>
+                <a:spcPts val="400"/>
+              </a:spcAft>
+            </a:pPr>
+            <a:r>
+              <a:rPr sz="850" b="0">
+                <a:solidFill>
+                  <a:srgbClr val="8A929E"/>
+                </a:solidFill>
+                <a:latin typeface="Apple SD Gothic Neo"/>
+              </a:rPr>
+              <a:t>출처: Anthropic System Card · Vellum 벤치마크 해설 (2026.5)</a:t>
+            </a:r>
+          </a:p>
+        </p:txBody>
+      </p:sp>
+      <p:sp>
+        <p:nvSpPr>
+          <p:cNvPr id="12" name="TextBox 11"/>
           <p:cNvSpPr txBox="1"/>
           <p:nvPr/>
         </p:nvSpPr>
@@ -8315,7 +8601,7 @@
                 </a:solidFill>
                 <a:latin typeface="Apple SD Gothic Neo"/>
               </a:rPr>
-              <a:t>MATH-500 = 중·고등~대학 초급 수학  |  AIME = 올림피아드급  |  FrontierMath = 연구자도 어려운 최고난도</a:t>
+              <a:t>MATH-500 = 중·고등~대학 초급 수학  |  AIME = 올림피아드급  |  FrontierMath = 최고난도</a:t>
             </a:r>
           </a:p>
           <a:p>
@@ -8334,7 +8620,7 @@
                 </a:solidFill>
                 <a:latin typeface="Apple SD Gothic Neo"/>
               </a:rPr>
-              <a:t>쉬운 수학은 GPT·Gemini·Grok도 94%↑  |  어려울수록 점수 차이가 커짐</a:t>
+              <a:t>쉬운 수학은 모두 94%↑  |  어려울수록 점수 차이가 커짐</a:t>
             </a:r>
           </a:p>
         </p:txBody>
@@ -8348,8 +8634,8 @@
           <p:nvPr/>
         </p:nvGraphicFramePr>
         <p:xfrm>
-          <a:off x="457200" y="1627632"/>
-          <a:ext cx="11247120" cy="3337560"/>
+          <a:off x="411480" y="1627632"/>
+          <a:ext cx="5440680" cy="1965960"/>
         </p:xfrm>
         <a:graphic>
           <a:graphicData uri="http://schemas.openxmlformats.org/drawingml/2006/chart">
@@ -8357,16 +8643,34 @@
           </a:graphicData>
         </a:graphic>
       </p:graphicFrame>
-      <p:sp>
-        <p:nvSpPr>
-          <p:cNvPr id="8" name="Rounded Rectangle 7"/>
+      <p:graphicFrame>
+        <p:nvGraphicFramePr>
+          <p:cNvPr id="8" name="Chart 7"/>
+          <p:cNvGraphicFramePr>
+            <a:graphicFrameLocks noGrp="1"/>
+          </p:cNvGraphicFramePr>
+          <p:nvPr/>
+        </p:nvGraphicFramePr>
+        <p:xfrm>
+          <a:off x="6263640" y="1627632"/>
+          <a:ext cx="5440680" cy="1965960"/>
+        </p:xfrm>
+        <a:graphic>
+          <a:graphicData uri="http://schemas.openxmlformats.org/drawingml/2006/chart">
+            <c:chart xmlns:c="http://schemas.openxmlformats.org/drawingml/2006/chart" r:id="rId3"/>
+          </a:graphicData>
+        </a:graphic>
+      </p:graphicFrame>
+      <p:sp>
+        <p:nvSpPr>
+          <p:cNvPr id="9" name="Rounded Rectangle 8"/>
           <p:cNvSpPr/>
           <p:nvPr/>
         </p:nvSpPr>
         <p:spPr>
           <a:xfrm>
-            <a:off x="457200" y="5074920"/>
-            <a:ext cx="11292840" cy="960120"/>
+            <a:off x="457200" y="3886200"/>
+            <a:ext cx="11292840" cy="914400"/>
           </a:xfrm>
           <a:prstGeom prst="roundRect">
             <a:avLst/>
@@ -8403,14 +8707,14 @@
       </p:sp>
       <p:sp>
         <p:nvSpPr>
-          <p:cNvPr id="9" name="TextBox 8"/>
+          <p:cNvPr id="10" name="TextBox 9"/>
           <p:cNvSpPr txBox="1"/>
           <p:nvPr/>
         </p:nvSpPr>
         <p:spPr>
           <a:xfrm>
-            <a:off x="640080" y="5074920"/>
-            <a:ext cx="10927080" cy="960120"/>
+            <a:off x="640080" y="3886200"/>
+            <a:ext cx="10927080" cy="914400"/>
           </a:xfrm>
           <a:prstGeom prst="rect">
             <a:avLst/>
@@ -8457,7 +8761,7 @@
                 </a:solidFill>
                 <a:latin typeface="Apple SD Gothic Neo"/>
               </a:rPr>
-              <a:t>일반·올림피아드 수학 → GPT·Grok·Gemini 앞섬 (95~97%)</a:t>
+              <a:t>일반·올림피아드 수학 → GPT 97% 1위 (Claude·Gemini·Grok도 95% 이상)</a:t>
             </a:r>
           </a:p>
           <a:p>
@@ -8476,14 +8780,56 @@
                 </a:solidFill>
                 <a:latin typeface="Apple SD Gothic Neo"/>
               </a:rPr>
-              <a:t>최고난도 수학(FrontierMath) → Grok 54% 1위  |  HW팀: 계산·수식 많은 업무는 GPT, 초난도는 Grok도 검토</a:t>
-            </a:r>
-          </a:p>
-        </p:txBody>
-      </p:sp>
-      <p:sp>
-        <p:nvSpPr>
-          <p:cNvPr id="10" name="TextBox 9"/>
+              <a:t>최고난도 수학(FrontierMath) → Grok 54% 1위</a:t>
+            </a:r>
+          </a:p>
+        </p:txBody>
+      </p:sp>
+      <p:sp>
+        <p:nvSpPr>
+          <p:cNvPr id="11" name="TextBox 10"/>
+          <p:cNvSpPr txBox="1"/>
+          <p:nvPr/>
+        </p:nvSpPr>
+        <p:spPr>
+          <a:xfrm>
+            <a:off x="457200" y="6327648"/>
+            <a:ext cx="10515600" cy="201168"/>
+          </a:xfrm>
+          <a:prstGeom prst="rect">
+            <a:avLst/>
+          </a:prstGeom>
+          <a:noFill/>
+        </p:spPr>
+        <p:txBody>
+          <a:bodyPr wrap="square" anchor="t" lIns="25400" rIns="25400" tIns="25400" bIns="25400">
+            <a:spAutoFit/>
+          </a:bodyPr>
+          <a:lstStyle/>
+          <a:p>
+            <a:pPr algn="l">
+              <a:lnSpc>
+                <a:spcPct val="100000"/>
+              </a:lnSpc>
+              <a:spcAft>
+                <a:spcPts val="400"/>
+              </a:spcAft>
+            </a:pPr>
+            <a:r>
+              <a:rPr sz="850" b="0">
+                <a:solidFill>
+                  <a:srgbClr val="8A929E"/>
+                </a:solidFill>
+                <a:latin typeface="Apple SD Gothic Neo"/>
+              </a:rPr>
+              <a:t>출처: AI Magic · Vellum 벤치마크 비교 (2026.5) · FrontierMath 공식</a:t>
+            </a:r>
+          </a:p>
+        </p:txBody>
+      </p:sp>
+      <p:sp>
+        <p:nvSpPr>
+          <p:cNvPr id="12" name="TextBox 11"/>
           <p:cNvSpPr txBox="1"/>
           <p:nvPr/>
         </p:nvSpPr>
@@ -8716,7 +9062,7 @@
                 </a:solidFill>
                 <a:latin typeface="Apple SD Gothic Neo"/>
               </a:rPr>
-              <a:t>추론 ③ — 도구 쓰면 더 잘 푸는지 · 종합 정리</a:t>
+              <a:t>추론 ③ — 도구 사용 시 · 종합 정리</a:t>
             </a:r>
           </a:p>
         </p:txBody>
@@ -8816,14 +9162,13 @@
               </a:spcAft>
             </a:pPr>
             <a:r>
-              <a:rPr sz="1050" b="1">
+              <a:rPr sz="1000" b="1">
                 <a:solidFill>
                   <a:srgbClr val="142A4A"/>
                 </a:solidFill>
                 <a:latin typeface="Apple SD Gothic Neo"/>
               </a:rPr>
-              <a:t>코딩
-버그 수정</a:t>
+              <a:t>코딩 버그 수정</a:t>
             </a:r>
           </a:p>
           <a:p>
@@ -8855,7 +9200,7 @@
               </a:spcAft>
             </a:pPr>
             <a:r>
-              <a:rPr sz="950" b="0">
+              <a:rPr sz="900" b="0">
                 <a:solidFill>
                   <a:srgbClr val="444A55"/>
                 </a:solidFill>
@@ -8943,14 +9288,13 @@
               </a:spcAft>
             </a:pPr>
             <a:r>
-              <a:rPr sz="1050" b="1">
+              <a:rPr sz="1000" b="1">
                 <a:solidFill>
                   <a:srgbClr val="142A4A"/>
                 </a:solidFill>
                 <a:latin typeface="Apple SD Gothic Neo"/>
               </a:rPr>
-              <a:t>터미널
-명령어</a:t>
+              <a:t>터미널 명령어</a:t>
             </a:r>
           </a:p>
           <a:p>
@@ -8982,7 +9326,7 @@
               </a:spcAft>
             </a:pPr>
             <a:r>
-              <a:rPr sz="950" b="0">
+              <a:rPr sz="900" b="0">
                 <a:solidFill>
                   <a:srgbClr val="444A55"/>
                 </a:solidFill>
@@ -9070,14 +9414,13 @@
               </a:spcAft>
             </a:pPr>
             <a:r>
-              <a:rPr sz="1050" b="1">
+              <a:rPr sz="1000" b="1">
                 <a:solidFill>
                   <a:srgbClr val="142A4A"/>
                 </a:solidFill>
                 <a:latin typeface="Apple SD Gothic Neo"/>
               </a:rPr>
-              <a:t>PC
-직접 조작</a:t>
+              <a:t>PC 직접 조작</a:t>
             </a:r>
           </a:p>
           <a:p>
@@ -9109,7 +9452,7 @@
               </a:spcAft>
             </a:pPr>
             <a:r>
-              <a:rPr sz="950" b="0">
+              <a:rPr sz="900" b="0">
                 <a:solidFill>
                   <a:srgbClr val="444A55"/>
                 </a:solidFill>
@@ -9197,14 +9540,13 @@
               </a:spcAft>
             </a:pPr>
             <a:r>
-              <a:rPr sz="1050" b="1">
+              <a:rPr sz="1000" b="1">
                 <a:solidFill>
                   <a:srgbClr val="142A4A"/>
                 </a:solidFill>
                 <a:latin typeface="Apple SD Gothic Neo"/>
               </a:rPr>
-              <a:t>어려운
-생각</a:t>
+              <a:t>어려운 생각</a:t>
             </a:r>
           </a:p>
           <a:p>
@@ -9236,7 +9578,7 @@
               </a:spcAft>
             </a:pPr>
             <a:r>
-              <a:rPr sz="950" b="0">
+              <a:rPr sz="900" b="0">
                 <a:solidFill>
                   <a:srgbClr val="444A55"/>
                 </a:solidFill>
@@ -9324,14 +9666,13 @@
               </a:spcAft>
             </a:pPr>
             <a:r>
-              <a:rPr sz="1050" b="1">
+              <a:rPr sz="1000" b="1">
                 <a:solidFill>
                   <a:srgbClr val="142A4A"/>
                 </a:solidFill>
                 <a:latin typeface="Apple SD Gothic Neo"/>
               </a:rPr>
-              <a:t>과학
-퀴즈</a:t>
+              <a:t>과학 퀴즈</a:t>
             </a:r>
           </a:p>
           <a:p>
@@ -9363,7 +9704,7 @@
               </a:spcAft>
             </a:pPr>
             <a:r>
-              <a:rPr sz="950" b="0">
+              <a:rPr sz="900" b="0">
                 <a:solidFill>
                   <a:srgbClr val="444A55"/>
                 </a:solidFill>
@@ -9451,14 +9792,13 @@
               </a:spcAft>
             </a:pPr>
             <a:r>
-              <a:rPr sz="1050" b="1">
+              <a:rPr sz="1000" b="1">
                 <a:solidFill>
                   <a:srgbClr val="142A4A"/>
                 </a:solidFill>
                 <a:latin typeface="Apple SD Gothic Neo"/>
               </a:rPr>
-              <a:t>최고난도
-수학</a:t>
+              <a:t>최고난도 수학</a:t>
             </a:r>
           </a:p>
           <a:p>
@@ -9490,7 +9830,7 @@
               </a:spcAft>
             </a:pPr>
             <a:r>
-              <a:rPr sz="950" b="0">
+              <a:rPr sz="900" b="0">
                 <a:solidFill>
                   <a:srgbClr val="444A55"/>
                 </a:solidFill>
@@ -9509,8 +9849,8 @@
         </p:nvSpPr>
         <p:spPr>
           <a:xfrm>
-            <a:off x="457200" y="5230368"/>
-            <a:ext cx="11292840" cy="868680"/>
+            <a:off x="457200" y="5212080"/>
+            <a:ext cx="11292840" cy="777240"/>
           </a:xfrm>
           <a:prstGeom prst="roundRect">
             <a:avLst/>
@@ -9553,8 +9893,8 @@
         </p:nvSpPr>
         <p:spPr>
           <a:xfrm>
-            <a:off x="640080" y="5230368"/>
-            <a:ext cx="10927080" cy="868680"/>
+            <a:off x="640080" y="5212080"/>
+            <a:ext cx="10927080" cy="777240"/>
           </a:xfrm>
           <a:prstGeom prst="rect">
             <a:avLst/>
@@ -9601,33 +9941,56 @@
                 </a:solidFill>
                 <a:latin typeface="Apple SD Gothic Neo"/>
               </a:rPr>
-              <a:t>코딩·복잡한 생각 → Claude  |  터미널·수학 → GPT  |  과학 → Gemini  |  초난도 수학·저비용 → Grok</a:t>
-            </a:r>
-          </a:p>
+              <a:t>코딩·복잡한 생각 → Claude  |  터미널·수학 → GPT  |  과학 → Gemini  |  초난도 수학 → Grok</a:t>
+            </a:r>
+          </a:p>
+        </p:txBody>
+      </p:sp>
+      <p:sp>
+        <p:nvSpPr>
+          <p:cNvPr id="21" name="TextBox 20"/>
+          <p:cNvSpPr txBox="1"/>
+          <p:nvPr/>
+        </p:nvSpPr>
+        <p:spPr>
+          <a:xfrm>
+            <a:off x="457200" y="6327648"/>
+            <a:ext cx="10515600" cy="201168"/>
+          </a:xfrm>
+          <a:prstGeom prst="rect">
+            <a:avLst/>
+          </a:prstGeom>
+          <a:noFill/>
+        </p:spPr>
+        <p:txBody>
+          <a:bodyPr wrap="square" anchor="t" lIns="25400" rIns="25400" tIns="25400" bIns="25400">
+            <a:spAutoFit/>
+          </a:bodyPr>
+          <a:lstStyle/>
           <a:p>
             <a:pPr algn="l">
               <a:lnSpc>
-                <a:spcPct val="115000"/>
+                <a:spcPct val="100000"/>
               </a:lnSpc>
               <a:spcAft>
-                <a:spcPts val="200"/>
+                <a:spcPts val="400"/>
               </a:spcAft>
             </a:pPr>
             <a:r>
-              <a:rPr sz="1100" b="0">
-                <a:solidFill>
-                  <a:srgbClr val="FFFFFF"/>
+              <a:rPr sz="850" b="0">
+                <a:solidFill>
+                  <a:srgbClr val="8A929E"/>
                 </a:solidFill>
                 <a:latin typeface="Apple SD Gothic Neo"/>
               </a:rPr>
-              <a:t>시험마다 1등이 다름 → '우리 팀이 자주 하는 일'과 같은 시험 점수를 보면 선택이 쉬움</a:t>
-            </a:r>
-          </a:p>
-        </p:txBody>
-      </p:sp>
-      <p:sp>
-        <p:nvSpPr>
-          <p:cNvPr id="21" name="TextBox 20"/>
+              <a:t>출처: Anthropic System Card · Vellum · AI Magic (2026.5)</a:t>
+            </a:r>
+          </a:p>
+        </p:txBody>
+      </p:sp>
+      <p:sp>
+        <p:nvSpPr>
+          <p:cNvPr id="22" name="TextBox 21"/>
           <p:cNvSpPr txBox="1"/>
           <p:nvPr/>
         </p:nvSpPr>
@@ -9873,8 +10236,8 @@
         </p:nvSpPr>
         <p:spPr>
           <a:xfrm>
-            <a:off x="594360" y="1417320"/>
-            <a:ext cx="10972800" cy="4114800"/>
+            <a:off x="594360" y="1325880"/>
+            <a:ext cx="10972800" cy="4389120"/>
           </a:xfrm>
           <a:prstGeom prst="rect">
             <a:avLst/>
@@ -9889,7 +10252,7 @@
           <a:p>
             <a:pPr algn="l">
               <a:lnSpc>
-                <a:spcPct val="130000"/>
+                <a:spcPct val="125000"/>
               </a:lnSpc>
               <a:spcAft>
                 <a:spcPts val="400"/>
@@ -9902,13 +10265,13 @@
                 </a:solidFill>
                 <a:latin typeface="Apple SD Gothic Neo"/>
               </a:rPr>
-              <a:t>공식 자료 (각 AI 회사가 직접 공개한 시험 점수)</a:t>
+              <a:t>1차 — 공식 자료 (각 AI 회사가 직접 공개)</a:t>
             </a:r>
           </a:p>
           <a:p>
             <a:pPr algn="l">
               <a:lnSpc>
-                <a:spcPct val="130000"/>
+                <a:spcPct val="125000"/>
               </a:lnSpc>
               <a:spcAft>
                 <a:spcPts val="400"/>
@@ -9921,127 +10284,127 @@
                 </a:solidFill>
                 <a:latin typeface="Apple SD Gothic Neo"/>
               </a:rPr>
-              <a:t>Anthropic Claude Opus 4.8 System Card  ·  OpenAI GPT-5.5  ·  Google Gemini 3.1 Pro  ·  xAI Grok 4.3</a:t>
+              <a:t>• Anthropic Claude Opus 4.8 System Card (2026.5.28)</a:t>
             </a:r>
           </a:p>
           <a:p>
             <a:pPr algn="l">
               <a:lnSpc>
-                <a:spcPct val="130000"/>
+                <a:spcPct val="125000"/>
               </a:lnSpc>
               <a:spcAft>
                 <a:spcPts val="400"/>
               </a:spcAft>
             </a:pPr>
             <a:r>
-              <a:rPr sz="800" b="0">
+              <a:rPr sz="1150" b="0">
                 <a:solidFill>
                   <a:srgbClr val="444A55"/>
                 </a:solidFill>
                 <a:latin typeface="Apple SD Gothic Neo"/>
               </a:rPr>
-              <a:t/>
+              <a:t>• OpenAI GPT-5.5 System Card  ·  Google Gemini 3.1 Pro Model Card  ·  xAI Grok 4.3 Model Card</a:t>
             </a:r>
           </a:p>
           <a:p>
             <a:pPr algn="l">
               <a:lnSpc>
-                <a:spcPct val="130000"/>
+                <a:spcPct val="125000"/>
               </a:lnSpc>
               <a:spcAft>
                 <a:spcPts val="400"/>
               </a:spcAft>
             </a:pPr>
             <a:r>
-              <a:rPr sz="1400" b="1">
-                <a:solidFill>
-                  <a:srgbClr val="142A4A"/>
+              <a:rPr sz="800" b="0">
+                <a:solidFill>
+                  <a:srgbClr val="444A55"/>
                 </a:solidFill>
                 <a:latin typeface="Apple SD Gothic Neo"/>
               </a:rPr>
-              <a:t>독립 검증 (회사 말만 믿지 않고 다른 기관이 모아둔 자료)</a:t>
+              <a:t/>
             </a:r>
           </a:p>
           <a:p>
             <a:pPr algn="l">
               <a:lnSpc>
-                <a:spcPct val="130000"/>
+                <a:spcPct val="125000"/>
               </a:lnSpc>
               <a:spcAft>
                 <a:spcPts val="400"/>
               </a:spcAft>
             </a:pPr>
             <a:r>
-              <a:rPr sz="1150" b="0">
-                <a:solidFill>
-                  <a:srgbClr val="444A55"/>
+              <a:rPr sz="1400" b="1">
+                <a:solidFill>
+                  <a:srgbClr val="142A4A"/>
                 </a:solidFill>
                 <a:latin typeface="Apple SD Gothic Neo"/>
               </a:rPr>
-              <a:t>Artificial Analysis  ·  Vellum  ·  Weights &amp; Biases ml-news</a:t>
+              <a:t>2차 — 독립 검증 (회사 말만 믿지 않고 다른 기관이 확인)</a:t>
             </a:r>
           </a:p>
           <a:p>
             <a:pPr algn="l">
               <a:lnSpc>
-                <a:spcPct val="130000"/>
+                <a:spcPct val="125000"/>
               </a:lnSpc>
               <a:spcAft>
                 <a:spcPts val="400"/>
               </a:spcAft>
             </a:pPr>
             <a:r>
-              <a:rPr sz="800" b="0">
+              <a:rPr sz="1150" b="0">
                 <a:solidFill>
                   <a:srgbClr val="444A55"/>
                 </a:solidFill>
                 <a:latin typeface="Apple SD Gothic Neo"/>
               </a:rPr>
-              <a:t/>
+              <a:t>• Artificial Analysis Intelligence Index  ·  Vellum 벤치마크 해설  ·  HundredTabs  ·  AI Magic</a:t>
             </a:r>
           </a:p>
           <a:p>
             <a:pPr algn="l">
               <a:lnSpc>
-                <a:spcPct val="130000"/>
+                <a:spcPct val="125000"/>
               </a:lnSpc>
               <a:spcAft>
                 <a:spcPts val="400"/>
               </a:spcAft>
             </a:pPr>
             <a:r>
-              <a:rPr sz="1400" b="1">
-                <a:solidFill>
-                  <a:srgbClr val="F27E2E"/>
+              <a:rPr sz="800" b="0">
+                <a:solidFill>
+                  <a:srgbClr val="444A55"/>
                 </a:solidFill>
                 <a:latin typeface="Apple SD Gothic Neo"/>
               </a:rPr>
-              <a:t>꼭 기억할 점</a:t>
+              <a:t/>
             </a:r>
           </a:p>
           <a:p>
             <a:pPr algn="l">
               <a:lnSpc>
-                <a:spcPct val="130000"/>
+                <a:spcPct val="125000"/>
               </a:lnSpc>
               <a:spcAft>
                 <a:spcPts val="400"/>
               </a:spcAft>
             </a:pPr>
             <a:r>
-              <a:rPr sz="1150" b="0">
-                <a:solidFill>
-                  <a:srgbClr val="444A55"/>
+              <a:rPr sz="1400" b="1">
+                <a:solidFill>
+                  <a:srgbClr val="F27E2E"/>
                 </a:solidFill>
                 <a:latin typeface="Apple SD Gothic Neo"/>
               </a:rPr>
-              <a:t>① 같은 시험이어도 측정 방법이 다르면 점수가 달라질 수 있음</a:t>
+              <a:t>꼭 기억할 점</a:t>
             </a:r>
           </a:p>
           <a:p>
             <a:pPr algn="l">
               <a:lnSpc>
-                <a:spcPct val="130000"/>
+                <a:spcPct val="125000"/>
               </a:lnSpc>
               <a:spcAft>
                 <a:spcPts val="400"/>
@@ -10054,13 +10417,32 @@
                 </a:solidFill>
                 <a:latin typeface="Apple SD Gothic Neo"/>
               </a:rPr>
-              <a:t>② * 표시는 공식 미공개라 근사치 — 보고 시 '약' 또는 '추정'으로 말하면 됨</a:t>
+              <a:t>① 같은 시험이어도 측정 방법이 다르면 점수가 달라질 수 있음</a:t>
             </a:r>
           </a:p>
           <a:p>
             <a:pPr algn="l">
               <a:lnSpc>
-                <a:spcPct val="130000"/>
+                <a:spcPct val="125000"/>
+              </a:lnSpc>
+              <a:spcAft>
+                <a:spcPts val="400"/>
+              </a:spcAft>
+            </a:pPr>
+            <a:r>
+              <a:rPr sz="1150" b="0">
+                <a:solidFill>
+                  <a:srgbClr val="444A55"/>
+                </a:solidFill>
+                <a:latin typeface="Apple SD Gothic Neo"/>
+              </a:rPr>
+              <a:t>② * 표시는 공식 미공개라 근사치 — 보고 시 '약' 또는 '추정'으로 말하기</a:t>
+            </a:r>
+          </a:p>
+          <a:p>
+            <a:pPr algn="l">
+              <a:lnSpc>
+                <a:spcPct val="125000"/>
               </a:lnSpc>
               <a:spcAft>
                 <a:spcPts val="400"/>

</xml_diff>